<commit_message>
docs: format demo prompts as code blocks and refresh deck
Wrap the demo prompts in fenced code blocks so they can be copied
verbatim during the presentation, add the self-contained-bundle
requirement to the build prompt, drop the skill-curation step, and
update the DBUG deck.

Co-Authored-By: Claude Opus 5 (1M context) <noreply@anthropic.com>
</commit_message>
<xml_diff>
--- a/docs/presentation/wanderbricks-dbug-deck.pptx
+++ b/docs/presentation/wanderbricks-dbug-deck.pptx
@@ -4,13 +4,17 @@
   <p:sldMasterIdLst>
     <p:sldMasterId id="2147483648" r:id="rId1"/>
   </p:sldMasterIdLst>
+  <p:notesMasterIdLst>
+    <p:notesMasterId r:id="rId9"/>
+  </p:notesMasterIdLst>
   <p:sldIdLst>
     <p:sldId id="256" r:id="rId2"/>
     <p:sldId id="257" r:id="rId3"/>
     <p:sldId id="258" r:id="rId4"/>
-    <p:sldId id="259" r:id="rId5"/>
-    <p:sldId id="260" r:id="rId6"/>
-    <p:sldId id="261" r:id="rId7"/>
+    <p:sldId id="262" r:id="rId5"/>
+    <p:sldId id="259" r:id="rId6"/>
+    <p:sldId id="260" r:id="rId7"/>
+    <p:sldId id="261" r:id="rId8"/>
   </p:sldIdLst>
   <p:sldSz cx="9144000" cy="5143500" type="screen16x9"/>
   <p:notesSz cx="6858000" cy="9144000"/>
@@ -128,6 +132,439 @@
 </p:presentation>
 </file>
 
+<file path=ppt/notesMasters/notesMaster1.xml><?xml version="1.0" encoding="utf-8"?>
+<p:notesMaster xmlns:a="http://schemas.openxmlformats.org/drawingml/2006/main" xmlns:r="http://schemas.openxmlformats.org/officeDocument/2006/relationships" xmlns:p="http://schemas.openxmlformats.org/presentationml/2006/main">
+  <p:cSld>
+    <p:bg>
+      <p:bgRef idx="1001">
+        <a:schemeClr val="bg1"/>
+      </p:bgRef>
+    </p:bg>
+    <p:spTree>
+      <p:nvGrpSpPr>
+        <p:cNvPr id="1" name=""/>
+        <p:cNvGrpSpPr/>
+        <p:nvPr/>
+      </p:nvGrpSpPr>
+      <p:grpSpPr>
+        <a:xfrm>
+          <a:off x="0" y="0"/>
+          <a:ext cx="0" cy="0"/>
+          <a:chOff x="0" y="0"/>
+          <a:chExt cx="0" cy="0"/>
+        </a:xfrm>
+      </p:grpSpPr>
+      <p:sp>
+        <p:nvSpPr>
+          <p:cNvPr id="2" name="Header Placeholder 1"/>
+          <p:cNvSpPr>
+            <a:spLocks noGrp="1"/>
+          </p:cNvSpPr>
+          <p:nvPr>
+            <p:ph type="hdr" sz="quarter"/>
+          </p:nvPr>
+        </p:nvSpPr>
+        <p:spPr>
+          <a:xfrm>
+            <a:off x="0" y="0"/>
+            <a:ext cx="2971800" cy="458788"/>
+          </a:xfrm>
+          <a:prstGeom prst="rect">
+            <a:avLst/>
+          </a:prstGeom>
+        </p:spPr>
+        <p:txBody>
+          <a:bodyPr vert="horz" lIns="91440" tIns="45720" rIns="91440" bIns="45720" rtlCol="0"/>
+          <a:lstStyle>
+            <a:lvl1pPr algn="l">
+              <a:defRPr sz="1200"/>
+            </a:lvl1pPr>
+          </a:lstStyle>
+          <a:p>
+            <a:endParaRPr lang="en-US"/>
+          </a:p>
+        </p:txBody>
+      </p:sp>
+      <p:sp>
+        <p:nvSpPr>
+          <p:cNvPr id="3" name="Date Placeholder 2"/>
+          <p:cNvSpPr>
+            <a:spLocks noGrp="1"/>
+          </p:cNvSpPr>
+          <p:nvPr>
+            <p:ph type="dt" idx="1"/>
+          </p:nvPr>
+        </p:nvSpPr>
+        <p:spPr>
+          <a:xfrm>
+            <a:off x="3884613" y="0"/>
+            <a:ext cx="2971800" cy="458788"/>
+          </a:xfrm>
+          <a:prstGeom prst="rect">
+            <a:avLst/>
+          </a:prstGeom>
+        </p:spPr>
+        <p:txBody>
+          <a:bodyPr vert="horz" lIns="91440" tIns="45720" rIns="91440" bIns="45720" rtlCol="0"/>
+          <a:lstStyle>
+            <a:lvl1pPr algn="r">
+              <a:defRPr sz="1200"/>
+            </a:lvl1pPr>
+          </a:lstStyle>
+          <a:p>
+            <a:fld id="{32B15507-4AC5-FD41-AEA4-5CE4886343C1}" type="datetimeFigureOut">
+              <a:rPr lang="en-US" smtClean="0"/>
+              <a:t>9/11/26</a:t>
+            </a:fld>
+            <a:endParaRPr lang="en-US"/>
+          </a:p>
+        </p:txBody>
+      </p:sp>
+      <p:sp>
+        <p:nvSpPr>
+          <p:cNvPr id="4" name="Slide Image Placeholder 3"/>
+          <p:cNvSpPr>
+            <a:spLocks noGrp="1" noRot="1" noChangeAspect="1"/>
+          </p:cNvSpPr>
+          <p:nvPr>
+            <p:ph type="sldImg" idx="2"/>
+          </p:nvPr>
+        </p:nvSpPr>
+        <p:spPr>
+          <a:xfrm>
+            <a:off x="685800" y="1143000"/>
+            <a:ext cx="5486400" cy="3086100"/>
+          </a:xfrm>
+          <a:prstGeom prst="rect">
+            <a:avLst/>
+          </a:prstGeom>
+          <a:noFill/>
+          <a:ln w="12700">
+            <a:solidFill>
+              <a:prstClr val="black"/>
+            </a:solidFill>
+          </a:ln>
+        </p:spPr>
+        <p:txBody>
+          <a:bodyPr vert="horz" lIns="91440" tIns="45720" rIns="91440" bIns="45720" rtlCol="0" anchor="ctr"/>
+          <a:lstStyle/>
+          <a:p>
+            <a:endParaRPr lang="en-US"/>
+          </a:p>
+        </p:txBody>
+      </p:sp>
+      <p:sp>
+        <p:nvSpPr>
+          <p:cNvPr id="5" name="Notes Placeholder 4"/>
+          <p:cNvSpPr>
+            <a:spLocks noGrp="1"/>
+          </p:cNvSpPr>
+          <p:nvPr>
+            <p:ph type="body" sz="quarter" idx="3"/>
+          </p:nvPr>
+        </p:nvSpPr>
+        <p:spPr>
+          <a:xfrm>
+            <a:off x="685800" y="4400550"/>
+            <a:ext cx="5486400" cy="3600450"/>
+          </a:xfrm>
+          <a:prstGeom prst="rect">
+            <a:avLst/>
+          </a:prstGeom>
+        </p:spPr>
+        <p:txBody>
+          <a:bodyPr vert="horz" lIns="91440" tIns="45720" rIns="91440" bIns="45720" rtlCol="0"/>
+          <a:lstStyle/>
+          <a:p>
+            <a:pPr lvl="0"/>
+            <a:r>
+              <a:rPr lang="en-US"/>
+              <a:t>Click to edit Master text styles</a:t>
+            </a:r>
+          </a:p>
+          <a:p>
+            <a:pPr lvl="1"/>
+            <a:r>
+              <a:rPr lang="en-US"/>
+              <a:t>Second level</a:t>
+            </a:r>
+          </a:p>
+          <a:p>
+            <a:pPr lvl="2"/>
+            <a:r>
+              <a:rPr lang="en-US"/>
+              <a:t>Third level</a:t>
+            </a:r>
+          </a:p>
+          <a:p>
+            <a:pPr lvl="3"/>
+            <a:r>
+              <a:rPr lang="en-US"/>
+              <a:t>Fourth level</a:t>
+            </a:r>
+          </a:p>
+          <a:p>
+            <a:pPr lvl="4"/>
+            <a:r>
+              <a:rPr lang="en-US"/>
+              <a:t>Fifth level</a:t>
+            </a:r>
+          </a:p>
+        </p:txBody>
+      </p:sp>
+      <p:sp>
+        <p:nvSpPr>
+          <p:cNvPr id="6" name="Footer Placeholder 5"/>
+          <p:cNvSpPr>
+            <a:spLocks noGrp="1"/>
+          </p:cNvSpPr>
+          <p:nvPr>
+            <p:ph type="ftr" sz="quarter" idx="4"/>
+          </p:nvPr>
+        </p:nvSpPr>
+        <p:spPr>
+          <a:xfrm>
+            <a:off x="0" y="8685213"/>
+            <a:ext cx="2971800" cy="458787"/>
+          </a:xfrm>
+          <a:prstGeom prst="rect">
+            <a:avLst/>
+          </a:prstGeom>
+        </p:spPr>
+        <p:txBody>
+          <a:bodyPr vert="horz" lIns="91440" tIns="45720" rIns="91440" bIns="45720" rtlCol="0" anchor="b"/>
+          <a:lstStyle>
+            <a:lvl1pPr algn="l">
+              <a:defRPr sz="1200"/>
+            </a:lvl1pPr>
+          </a:lstStyle>
+          <a:p>
+            <a:endParaRPr lang="en-US"/>
+          </a:p>
+        </p:txBody>
+      </p:sp>
+      <p:sp>
+        <p:nvSpPr>
+          <p:cNvPr id="7" name="Slide Number Placeholder 6"/>
+          <p:cNvSpPr>
+            <a:spLocks noGrp="1"/>
+          </p:cNvSpPr>
+          <p:nvPr>
+            <p:ph type="sldNum" sz="quarter" idx="5"/>
+          </p:nvPr>
+        </p:nvSpPr>
+        <p:spPr>
+          <a:xfrm>
+            <a:off x="3884613" y="8685213"/>
+            <a:ext cx="2971800" cy="458787"/>
+          </a:xfrm>
+          <a:prstGeom prst="rect">
+            <a:avLst/>
+          </a:prstGeom>
+        </p:spPr>
+        <p:txBody>
+          <a:bodyPr vert="horz" lIns="91440" tIns="45720" rIns="91440" bIns="45720" rtlCol="0" anchor="b"/>
+          <a:lstStyle>
+            <a:lvl1pPr algn="r">
+              <a:defRPr sz="1200"/>
+            </a:lvl1pPr>
+          </a:lstStyle>
+          <a:p>
+            <a:fld id="{F5FFF540-DF48-7040-BAC3-F01319E21FEB}" type="slidenum">
+              <a:rPr lang="en-US" smtClean="0"/>
+              <a:t>‹#›</a:t>
+            </a:fld>
+            <a:endParaRPr lang="en-US"/>
+          </a:p>
+        </p:txBody>
+      </p:sp>
+    </p:spTree>
+    <p:extLst>
+      <p:ext uri="{BB962C8B-B14F-4D97-AF65-F5344CB8AC3E}">
+        <p14:creationId xmlns:p14="http://schemas.microsoft.com/office/powerpoint/2010/main" val="2221376287"/>
+      </p:ext>
+    </p:extLst>
+  </p:cSld>
+  <p:clrMap bg1="lt1" tx1="dk1" bg2="lt2" tx2="dk2" accent1="accent1" accent2="accent2" accent3="accent3" accent4="accent4" accent5="accent5" accent6="accent6" hlink="hlink" folHlink="folHlink"/>
+  <p:notesStyle>
+    <a:lvl1pPr marL="0" algn="l" defTabSz="914400" rtl="0" eaLnBrk="1" latinLnBrk="0" hangingPunct="1">
+      <a:defRPr sz="1200" kern="1200">
+        <a:solidFill>
+          <a:schemeClr val="tx1"/>
+        </a:solidFill>
+        <a:latin typeface="+mn-lt"/>
+        <a:ea typeface="+mn-ea"/>
+        <a:cs typeface="+mn-cs"/>
+      </a:defRPr>
+    </a:lvl1pPr>
+    <a:lvl2pPr marL="457200" algn="l" defTabSz="914400" rtl="0" eaLnBrk="1" latinLnBrk="0" hangingPunct="1">
+      <a:defRPr sz="1200" kern="1200">
+        <a:solidFill>
+          <a:schemeClr val="tx1"/>
+        </a:solidFill>
+        <a:latin typeface="+mn-lt"/>
+        <a:ea typeface="+mn-ea"/>
+        <a:cs typeface="+mn-cs"/>
+      </a:defRPr>
+    </a:lvl2pPr>
+    <a:lvl3pPr marL="914400" algn="l" defTabSz="914400" rtl="0" eaLnBrk="1" latinLnBrk="0" hangingPunct="1">
+      <a:defRPr sz="1200" kern="1200">
+        <a:solidFill>
+          <a:schemeClr val="tx1"/>
+        </a:solidFill>
+        <a:latin typeface="+mn-lt"/>
+        <a:ea typeface="+mn-ea"/>
+        <a:cs typeface="+mn-cs"/>
+      </a:defRPr>
+    </a:lvl3pPr>
+    <a:lvl4pPr marL="1371600" algn="l" defTabSz="914400" rtl="0" eaLnBrk="1" latinLnBrk="0" hangingPunct="1">
+      <a:defRPr sz="1200" kern="1200">
+        <a:solidFill>
+          <a:schemeClr val="tx1"/>
+        </a:solidFill>
+        <a:latin typeface="+mn-lt"/>
+        <a:ea typeface="+mn-ea"/>
+        <a:cs typeface="+mn-cs"/>
+      </a:defRPr>
+    </a:lvl4pPr>
+    <a:lvl5pPr marL="1828800" algn="l" defTabSz="914400" rtl="0" eaLnBrk="1" latinLnBrk="0" hangingPunct="1">
+      <a:defRPr sz="1200" kern="1200">
+        <a:solidFill>
+          <a:schemeClr val="tx1"/>
+        </a:solidFill>
+        <a:latin typeface="+mn-lt"/>
+        <a:ea typeface="+mn-ea"/>
+        <a:cs typeface="+mn-cs"/>
+      </a:defRPr>
+    </a:lvl5pPr>
+    <a:lvl6pPr marL="2286000" algn="l" defTabSz="914400" rtl="0" eaLnBrk="1" latinLnBrk="0" hangingPunct="1">
+      <a:defRPr sz="1200" kern="1200">
+        <a:solidFill>
+          <a:schemeClr val="tx1"/>
+        </a:solidFill>
+        <a:latin typeface="+mn-lt"/>
+        <a:ea typeface="+mn-ea"/>
+        <a:cs typeface="+mn-cs"/>
+      </a:defRPr>
+    </a:lvl6pPr>
+    <a:lvl7pPr marL="2743200" algn="l" defTabSz="914400" rtl="0" eaLnBrk="1" latinLnBrk="0" hangingPunct="1">
+      <a:defRPr sz="1200" kern="1200">
+        <a:solidFill>
+          <a:schemeClr val="tx1"/>
+        </a:solidFill>
+        <a:latin typeface="+mn-lt"/>
+        <a:ea typeface="+mn-ea"/>
+        <a:cs typeface="+mn-cs"/>
+      </a:defRPr>
+    </a:lvl7pPr>
+    <a:lvl8pPr marL="3200400" algn="l" defTabSz="914400" rtl="0" eaLnBrk="1" latinLnBrk="0" hangingPunct="1">
+      <a:defRPr sz="1200" kern="1200">
+        <a:solidFill>
+          <a:schemeClr val="tx1"/>
+        </a:solidFill>
+        <a:latin typeface="+mn-lt"/>
+        <a:ea typeface="+mn-ea"/>
+        <a:cs typeface="+mn-cs"/>
+      </a:defRPr>
+    </a:lvl8pPr>
+    <a:lvl9pPr marL="3657600" algn="l" defTabSz="914400" rtl="0" eaLnBrk="1" latinLnBrk="0" hangingPunct="1">
+      <a:defRPr sz="1200" kern="1200">
+        <a:solidFill>
+          <a:schemeClr val="tx1"/>
+        </a:solidFill>
+        <a:latin typeface="+mn-lt"/>
+        <a:ea typeface="+mn-ea"/>
+        <a:cs typeface="+mn-cs"/>
+      </a:defRPr>
+    </a:lvl9pPr>
+  </p:notesStyle>
+</p:notesMaster>
+</file>
+
+<file path=ppt/notesSlides/notesSlide1.xml><?xml version="1.0" encoding="utf-8"?>
+<p:notes xmlns:a="http://schemas.openxmlformats.org/drawingml/2006/main" xmlns:r="http://schemas.openxmlformats.org/officeDocument/2006/relationships" xmlns:p="http://schemas.openxmlformats.org/presentationml/2006/main">
+  <p:cSld>
+    <p:spTree>
+      <p:nvGrpSpPr>
+        <p:cNvPr id="1" name=""/>
+        <p:cNvGrpSpPr/>
+        <p:nvPr/>
+      </p:nvGrpSpPr>
+      <p:grpSpPr>
+        <a:xfrm>
+          <a:off x="0" y="0"/>
+          <a:ext cx="0" cy="0"/>
+          <a:chOff x="0" y="0"/>
+          <a:chExt cx="0" cy="0"/>
+        </a:xfrm>
+      </p:grpSpPr>
+      <p:sp>
+        <p:nvSpPr>
+          <p:cNvPr id="2" name="Slide Image Placeholder 1"/>
+          <p:cNvSpPr>
+            <a:spLocks noGrp="1" noRot="1" noChangeAspect="1"/>
+          </p:cNvSpPr>
+          <p:nvPr>
+            <p:ph type="sldImg"/>
+          </p:nvPr>
+        </p:nvSpPr>
+        <p:spPr/>
+      </p:sp>
+      <p:sp>
+        <p:nvSpPr>
+          <p:cNvPr id="3" name="Notes Placeholder 2"/>
+          <p:cNvSpPr>
+            <a:spLocks noGrp="1"/>
+          </p:cNvSpPr>
+          <p:nvPr>
+            <p:ph type="body" idx="1"/>
+          </p:nvPr>
+        </p:nvSpPr>
+        <p:spPr/>
+        <p:txBody>
+          <a:bodyPr/>
+          <a:lstStyle/>
+          <a:p>
+            <a:endParaRPr lang="en-US" dirty="0"/>
+          </a:p>
+        </p:txBody>
+      </p:sp>
+      <p:sp>
+        <p:nvSpPr>
+          <p:cNvPr id="4" name="Slide Number Placeholder 3"/>
+          <p:cNvSpPr>
+            <a:spLocks noGrp="1"/>
+          </p:cNvSpPr>
+          <p:nvPr>
+            <p:ph type="sldNum" sz="quarter" idx="5"/>
+          </p:nvPr>
+        </p:nvSpPr>
+        <p:spPr/>
+        <p:txBody>
+          <a:bodyPr/>
+          <a:lstStyle/>
+          <a:p>
+            <a:fld id="{F5FFF540-DF48-7040-BAC3-F01319E21FEB}" type="slidenum">
+              <a:rPr lang="en-US" smtClean="0"/>
+              <a:t>4</a:t>
+            </a:fld>
+            <a:endParaRPr lang="en-US"/>
+          </a:p>
+        </p:txBody>
+      </p:sp>
+    </p:spTree>
+    <p:extLst>
+      <p:ext uri="{BB962C8B-B14F-4D97-AF65-F5344CB8AC3E}">
+        <p14:creationId xmlns:p14="http://schemas.microsoft.com/office/powerpoint/2010/main" val="2363482850"/>
+      </p:ext>
+    </p:extLst>
+  </p:cSld>
+  <p:clrMapOvr>
+    <a:masterClrMapping/>
+  </p:clrMapOvr>
+</p:notes>
+</file>
+
 <file path=ppt/slideLayouts/slideLayout1.xml><?xml version="1.0" encoding="utf-8"?>
 <p:sldLayout xmlns:a="http://schemas.openxmlformats.org/drawingml/2006/main" xmlns:r="http://schemas.openxmlformats.org/officeDocument/2006/relationships" xmlns:p="http://schemas.openxmlformats.org/presentationml/2006/main" type="title" preserve="1">
   <p:cSld name="Title Slide">
@@ -307,7 +744,7 @@
           <a:p>
             <a:fld id="{5BCAD085-E8A6-8845-BD4E-CB4CCA059FC4}" type="datetimeFigureOut">
               <a:rPr lang="en-US" smtClean="0"/>
-              <a:t>9/10/26</a:t>
+              <a:t>9/11/26</a:t>
             </a:fld>
             <a:endParaRPr lang="en-US"/>
           </a:p>
@@ -475,7 +912,7 @@
           <a:p>
             <a:fld id="{5BCAD085-E8A6-8845-BD4E-CB4CCA059FC4}" type="datetimeFigureOut">
               <a:rPr lang="en-US" smtClean="0"/>
-              <a:t>9/10/26</a:t>
+              <a:t>9/11/26</a:t>
             </a:fld>
             <a:endParaRPr lang="en-US"/>
           </a:p>
@@ -653,7 +1090,7 @@
           <a:p>
             <a:fld id="{5BCAD085-E8A6-8845-BD4E-CB4CCA059FC4}" type="datetimeFigureOut">
               <a:rPr lang="en-US" smtClean="0"/>
-              <a:t>9/10/26</a:t>
+              <a:t>9/11/26</a:t>
             </a:fld>
             <a:endParaRPr lang="en-US"/>
           </a:p>
@@ -821,7 +1258,7 @@
           <a:p>
             <a:fld id="{5BCAD085-E8A6-8845-BD4E-CB4CCA059FC4}" type="datetimeFigureOut">
               <a:rPr lang="en-US" smtClean="0"/>
-              <a:t>9/10/26</a:t>
+              <a:t>9/11/26</a:t>
             </a:fld>
             <a:endParaRPr lang="en-US"/>
           </a:p>
@@ -1066,7 +1503,7 @@
           <a:p>
             <a:fld id="{5BCAD085-E8A6-8845-BD4E-CB4CCA059FC4}" type="datetimeFigureOut">
               <a:rPr lang="en-US" smtClean="0"/>
-              <a:t>9/10/26</a:t>
+              <a:t>9/11/26</a:t>
             </a:fld>
             <a:endParaRPr lang="en-US"/>
           </a:p>
@@ -1351,7 +1788,7 @@
           <a:p>
             <a:fld id="{5BCAD085-E8A6-8845-BD4E-CB4CCA059FC4}" type="datetimeFigureOut">
               <a:rPr lang="en-US" smtClean="0"/>
-              <a:t>9/10/26</a:t>
+              <a:t>9/11/26</a:t>
             </a:fld>
             <a:endParaRPr lang="en-US"/>
           </a:p>
@@ -1770,7 +2207,7 @@
           <a:p>
             <a:fld id="{5BCAD085-E8A6-8845-BD4E-CB4CCA059FC4}" type="datetimeFigureOut">
               <a:rPr lang="en-US" smtClean="0"/>
-              <a:t>9/10/26</a:t>
+              <a:t>9/11/26</a:t>
             </a:fld>
             <a:endParaRPr lang="en-US"/>
           </a:p>
@@ -1887,7 +2324,7 @@
           <a:p>
             <a:fld id="{5BCAD085-E8A6-8845-BD4E-CB4CCA059FC4}" type="datetimeFigureOut">
               <a:rPr lang="en-US" smtClean="0"/>
-              <a:t>9/10/26</a:t>
+              <a:t>9/11/26</a:t>
             </a:fld>
             <a:endParaRPr lang="en-US"/>
           </a:p>
@@ -1982,7 +2419,7 @@
           <a:p>
             <a:fld id="{5BCAD085-E8A6-8845-BD4E-CB4CCA059FC4}" type="datetimeFigureOut">
               <a:rPr lang="en-US" smtClean="0"/>
-              <a:t>9/10/26</a:t>
+              <a:t>9/11/26</a:t>
             </a:fld>
             <a:endParaRPr lang="en-US"/>
           </a:p>
@@ -2257,7 +2694,7 @@
           <a:p>
             <a:fld id="{5BCAD085-E8A6-8845-BD4E-CB4CCA059FC4}" type="datetimeFigureOut">
               <a:rPr lang="en-US" smtClean="0"/>
-              <a:t>9/10/26</a:t>
+              <a:t>9/11/26</a:t>
             </a:fld>
             <a:endParaRPr lang="en-US"/>
           </a:p>
@@ -2509,7 +2946,7 @@
           <a:p>
             <a:fld id="{5BCAD085-E8A6-8845-BD4E-CB4CCA059FC4}" type="datetimeFigureOut">
               <a:rPr lang="en-US" smtClean="0"/>
-              <a:t>9/10/26</a:t>
+              <a:t>9/11/26</a:t>
             </a:fld>
             <a:endParaRPr lang="en-US"/>
           </a:p>
@@ -2720,7 +3157,7 @@
           <a:p>
             <a:fld id="{5BCAD085-E8A6-8845-BD4E-CB4CCA059FC4}" type="datetimeFigureOut">
               <a:rPr lang="en-US" smtClean="0"/>
-              <a:t>9/10/26</a:t>
+              <a:t>9/11/26</a:t>
             </a:fld>
             <a:endParaRPr lang="en-US"/>
           </a:p>
@@ -5712,13 +6149,13 @@
           <a:p>
             <a:pPr algn="l"/>
             <a:r>
-              <a:rPr sz="2400" b="1" i="0">
+              <a:rPr sz="2400" b="1">
                 <a:solidFill>
                   <a:srgbClr val="141712"/>
                 </a:solidFill>
                 <a:latin typeface="Calibri"/>
               </a:rPr>
-              <a:t>Best Practices</a:t>
+              <a:t>Why the AI Dev Kit</a:t>
             </a:r>
           </a:p>
         </p:txBody>
@@ -5747,13 +6184,13 @@
           <a:p>
             <a:pPr algn="l"/>
             <a:r>
-              <a:rPr sz="1000" b="0" i="0">
+              <a:rPr sz="1000" b="0">
                 <a:solidFill>
                   <a:srgbClr val="77766E"/>
                 </a:solidFill>
                 <a:latin typeface="Calibri"/>
               </a:rPr>
-              <a:t>02 / Install &amp; Configure</a:t>
+              <a:t>01 / Overview</a:t>
             </a:r>
           </a:p>
         </p:txBody>
@@ -5805,14 +6242,14 @@
       </p:sp>
       <p:pic>
         <p:nvPicPr>
-          <p:cNvPr id="7" name="Picture 6" descr="origin-logo-02.png"/>
+          <p:cNvPr id="7" name="Picture 6" descr="image.png"/>
           <p:cNvPicPr>
             <a:picLocks noChangeAspect="1"/>
           </p:cNvPicPr>
           <p:nvPr/>
         </p:nvPicPr>
         <p:blipFill>
-          <a:blip r:embed="rId2"/>
+          <a:blip r:embed="rId3"/>
           <a:stretch>
             <a:fillRect/>
           </a:stretch>
@@ -5829,14 +6266,49 @@
       </p:pic>
       <p:sp>
         <p:nvSpPr>
-          <p:cNvPr id="8" name="Rectangle 7"/>
+          <p:cNvPr id="8" name="TextBox 7"/>
+          <p:cNvSpPr txBox="1"/>
+          <p:nvPr/>
+        </p:nvSpPr>
+        <p:spPr>
+          <a:xfrm>
+            <a:off x="368300" y="1270000"/>
+            <a:ext cx="8407400" cy="508000"/>
+          </a:xfrm>
+          <a:prstGeom prst="rect">
+            <a:avLst/>
+          </a:prstGeom>
+          <a:noFill/>
+        </p:spPr>
+        <p:txBody>
+          <a:bodyPr wrap="square" lIns="0" tIns="0" rIns="0" bIns="0" anchor="t">
+            <a:spAutoFit/>
+          </a:bodyPr>
+          <a:lstStyle/>
+          <a:p>
+            <a:pPr algn="l"/>
+            <a:r>
+              <a:rPr sz="1400" b="1">
+                <a:solidFill>
+                  <a:srgbClr val="141712"/>
+                </a:solidFill>
+                <a:latin typeface="Calibri"/>
+              </a:rPr>
+              <a:t>Compared with Genie or a pile of custom skills, this keeps you in control.</a:t>
+            </a:r>
+          </a:p>
+        </p:txBody>
+      </p:sp>
+      <p:sp>
+        <p:nvSpPr>
+          <p:cNvPr id="9" name="Rectangle 8"/>
           <p:cNvSpPr/>
           <p:nvPr/>
         </p:nvSpPr>
         <p:spPr>
           <a:xfrm>
-            <a:off x="368300" y="1270000"/>
-            <a:ext cx="8407400" cy="990600"/>
+            <a:off x="368300" y="2032000"/>
+            <a:ext cx="8407400" cy="787400"/>
           </a:xfrm>
           <a:prstGeom prst="rect">
             <a:avLst/>
@@ -5874,16 +6346,16 @@
       </p:sp>
       <p:sp>
         <p:nvSpPr>
-          <p:cNvPr id="9" name="Rounded Rectangle 8"/>
+          <p:cNvPr id="10" name="Rectangle 9"/>
           <p:cNvSpPr/>
           <p:nvPr/>
         </p:nvSpPr>
         <p:spPr>
           <a:xfrm>
-            <a:off x="368300" y="1562100"/>
-            <a:ext cx="406400" cy="406400"/>
-          </a:xfrm>
-          <a:prstGeom prst="roundRect">
+            <a:off x="368300" y="2032000"/>
+            <a:ext cx="50800" cy="787400"/>
+          </a:xfrm>
+          <a:prstGeom prst="rect">
             <a:avLst/>
           </a:prstGeom>
           <a:solidFill>
@@ -5913,28 +6385,20 @@
           <a:lstStyle/>
           <a:p>
             <a:pPr algn="ctr"/>
-            <a:r>
-              <a:rPr sz="1400" b="1">
-                <a:solidFill>
-                  <a:srgbClr val="141712"/>
-                </a:solidFill>
-                <a:latin typeface="Calibri"/>
-              </a:rPr>
-              <a:t>1</a:t>
-            </a:r>
-          </a:p>
-        </p:txBody>
-      </p:sp>
-      <p:sp>
-        <p:nvSpPr>
-          <p:cNvPr id="10" name="TextBox 9"/>
+            <a:endParaRPr/>
+          </a:p>
+        </p:txBody>
+      </p:sp>
+      <p:sp>
+        <p:nvSpPr>
+          <p:cNvPr id="11" name="TextBox 10"/>
           <p:cNvSpPr txBox="1"/>
           <p:nvPr/>
         </p:nvSpPr>
         <p:spPr>
           <a:xfrm>
-            <a:off x="990600" y="1397000"/>
-            <a:ext cx="7620000" cy="228600"/>
+            <a:off x="571500" y="2133600"/>
+            <a:ext cx="8007400" cy="228600"/>
           </a:xfrm>
           <a:prstGeom prst="rect">
             <a:avLst/>
@@ -5949,27 +6413,27 @@
           <a:p>
             <a:pPr algn="l"/>
             <a:r>
-              <a:rPr sz="1200" b="1" i="0">
+              <a:rPr sz="1600" b="1">
                 <a:solidFill>
                   <a:srgbClr val="ADFF26"/>
                 </a:solidFill>
                 <a:latin typeface="Calibri"/>
               </a:rPr>
-              <a:t>Curate which skills auto-trigger</a:t>
-            </a:r>
-          </a:p>
-        </p:txBody>
-      </p:sp>
-      <p:sp>
-        <p:nvSpPr>
-          <p:cNvPr id="11" name="TextBox 10"/>
+              <a:t>Stay in your IDE</a:t>
+            </a:r>
+          </a:p>
+        </p:txBody>
+      </p:sp>
+      <p:sp>
+        <p:nvSpPr>
+          <p:cNvPr id="12" name="TextBox 11"/>
           <p:cNvSpPr txBox="1"/>
           <p:nvPr/>
         </p:nvSpPr>
         <p:spPr>
           <a:xfrm>
-            <a:off x="990600" y="1651000"/>
-            <a:ext cx="7620000" cy="558800"/>
+            <a:off x="571500" y="2387600"/>
+            <a:ext cx="8007400" cy="330000"/>
           </a:xfrm>
           <a:prstGeom prst="rect">
             <a:avLst/>
@@ -5982,33 +6446,29 @@
           </a:bodyPr>
           <a:lstStyle/>
           <a:p>
-            <a:pPr algn="l">
-              <a:lnSpc>
-                <a:spcPct val="115000"/>
-              </a:lnSpc>
-            </a:pPr>
-            <a:r>
-              <a:rPr sz="1100" b="0" i="0">
+            <a:pPr algn="l"/>
+            <a:r>
+              <a:rPr sz="1100" b="0">
                 <a:solidFill>
                   <a:srgbClr val="FFFFFF"/>
                 </a:solidFill>
                 <a:latin typeface="Calibri"/>
               </a:rPr>
-              <a:t>Avoid skill sprawl: set most databricks-* skills to "user-invokable-only" in .claude/settings.local.json — keep databricks-core, databricks-docs, databricks-python-sdk, and databricks-unity-catalog "on".</a:t>
-            </a:r>
-          </a:p>
-        </p:txBody>
-      </p:sp>
-      <p:sp>
-        <p:nvSpPr>
-          <p:cNvPr id="12" name="Rectangle 11"/>
+              <a:t>Keep your own custom skills and workflow -- no new tool, no context switch.</a:t>
+            </a:r>
+          </a:p>
+        </p:txBody>
+      </p:sp>
+      <p:sp>
+        <p:nvSpPr>
+          <p:cNvPr id="13" name="Rectangle 12"/>
           <p:cNvSpPr/>
           <p:nvPr/>
         </p:nvSpPr>
         <p:spPr>
           <a:xfrm>
-            <a:off x="368300" y="2387600"/>
-            <a:ext cx="8407400" cy="990600"/>
+            <a:off x="368300" y="2946400"/>
+            <a:ext cx="8407400" cy="787400"/>
           </a:xfrm>
           <a:prstGeom prst="rect">
             <a:avLst/>
@@ -6046,16 +6506,16 @@
       </p:sp>
       <p:sp>
         <p:nvSpPr>
-          <p:cNvPr id="13" name="Rounded Rectangle 12"/>
+          <p:cNvPr id="14" name="Rectangle 13"/>
           <p:cNvSpPr/>
           <p:nvPr/>
         </p:nvSpPr>
         <p:spPr>
           <a:xfrm>
-            <a:off x="368300" y="2679700"/>
-            <a:ext cx="406400" cy="406400"/>
-          </a:xfrm>
-          <a:prstGeom prst="roundRect">
+            <a:off x="368300" y="2946400"/>
+            <a:ext cx="50800" cy="787400"/>
+          </a:xfrm>
+          <a:prstGeom prst="rect">
             <a:avLst/>
           </a:prstGeom>
           <a:solidFill>
@@ -6085,28 +6545,20 @@
           <a:lstStyle/>
           <a:p>
             <a:pPr algn="ctr"/>
-            <a:r>
-              <a:rPr sz="1400" b="1">
-                <a:solidFill>
-                  <a:srgbClr val="141712"/>
-                </a:solidFill>
-                <a:latin typeface="Calibri"/>
-              </a:rPr>
-              <a:t>2</a:t>
-            </a:r>
-          </a:p>
-        </p:txBody>
-      </p:sp>
-      <p:sp>
-        <p:nvSpPr>
-          <p:cNvPr id="14" name="TextBox 13"/>
+            <a:endParaRPr/>
+          </a:p>
+        </p:txBody>
+      </p:sp>
+      <p:sp>
+        <p:nvSpPr>
+          <p:cNvPr id="15" name="TextBox 14"/>
           <p:cNvSpPr txBox="1"/>
           <p:nvPr/>
         </p:nvSpPr>
         <p:spPr>
           <a:xfrm>
-            <a:off x="990600" y="2514600"/>
-            <a:ext cx="7620000" cy="228600"/>
+            <a:off x="571500" y="3048000"/>
+            <a:ext cx="8007400" cy="228600"/>
           </a:xfrm>
           <a:prstGeom prst="rect">
             <a:avLst/>
@@ -6121,27 +6573,27 @@
           <a:p>
             <a:pPr algn="l"/>
             <a:r>
-              <a:rPr sz="1200" b="1" i="0">
+              <a:rPr sz="1600" b="1">
                 <a:solidFill>
                   <a:srgbClr val="ADFF26"/>
                 </a:solidFill>
                 <a:latin typeface="Calibri"/>
               </a:rPr>
-              <a:t>Reload after config changes</a:t>
-            </a:r>
-          </a:p>
-        </p:txBody>
-      </p:sp>
-      <p:sp>
-        <p:nvSpPr>
-          <p:cNvPr id="15" name="TextBox 14"/>
+              <a:t>Delegate the boring 80%</a:t>
+            </a:r>
+          </a:p>
+        </p:txBody>
+      </p:sp>
+      <p:sp>
+        <p:nvSpPr>
+          <p:cNvPr id="16" name="TextBox 15"/>
           <p:cNvSpPr txBox="1"/>
           <p:nvPr/>
         </p:nvSpPr>
         <p:spPr>
           <a:xfrm>
-            <a:off x="990600" y="2768600"/>
-            <a:ext cx="7620000" cy="558800"/>
+            <a:off x="571500" y="3302000"/>
+            <a:ext cx="8007400" cy="330000"/>
           </a:xfrm>
           <a:prstGeom prst="rect">
             <a:avLst/>
@@ -6154,33 +6606,29 @@
           </a:bodyPr>
           <a:lstStyle/>
           <a:p>
-            <a:pPr algn="l">
-              <a:lnSpc>
-                <a:spcPct val="115000"/>
-              </a:lnSpc>
-            </a:pPr>
-            <a:r>
-              <a:rPr sz="1100" b="0" i="0">
+            <a:pPr algn="l"/>
+            <a:r>
+              <a:rPr sz="1100" b="0">
                 <a:solidFill>
                   <a:srgbClr val="FFFFFF"/>
                 </a:solidFill>
                 <a:latin typeface="Calibri"/>
               </a:rPr>
-              <a:t>Run /reload-skills so the agent picks up new skill overrides right away.</a:t>
-            </a:r>
-          </a:p>
-        </p:txBody>
-      </p:sp>
-      <p:sp>
-        <p:nvSpPr>
-          <p:cNvPr id="16" name="Rectangle 15"/>
+              <a:t>Claude handles CLI auth, bundle scaffolding, and boilerplate work on its own.</a:t>
+            </a:r>
+          </a:p>
+        </p:txBody>
+      </p:sp>
+      <p:sp>
+        <p:nvSpPr>
+          <p:cNvPr id="17" name="Rectangle 16"/>
           <p:cNvSpPr/>
           <p:nvPr/>
         </p:nvSpPr>
         <p:spPr>
           <a:xfrm>
-            <a:off x="368300" y="3505200"/>
-            <a:ext cx="8407400" cy="990600"/>
+            <a:off x="368300" y="3860800"/>
+            <a:ext cx="8407400" cy="787400"/>
           </a:xfrm>
           <a:prstGeom prst="rect">
             <a:avLst/>
@@ -6218,16 +6666,16 @@
       </p:sp>
       <p:sp>
         <p:nvSpPr>
-          <p:cNvPr id="17" name="Rounded Rectangle 16"/>
+          <p:cNvPr id="18" name="Rectangle 17"/>
           <p:cNvSpPr/>
           <p:nvPr/>
         </p:nvSpPr>
         <p:spPr>
           <a:xfrm>
-            <a:off x="368300" y="3797300"/>
-            <a:ext cx="406400" cy="406400"/>
-          </a:xfrm>
-          <a:prstGeom prst="roundRect">
+            <a:off x="368300" y="3860800"/>
+            <a:ext cx="50800" cy="787400"/>
+          </a:xfrm>
+          <a:prstGeom prst="rect">
             <a:avLst/>
           </a:prstGeom>
           <a:solidFill>
@@ -6257,28 +6705,20 @@
           <a:lstStyle/>
           <a:p>
             <a:pPr algn="ctr"/>
-            <a:r>
-              <a:rPr sz="1400" b="1">
-                <a:solidFill>
-                  <a:srgbClr val="141712"/>
-                </a:solidFill>
-                <a:latin typeface="Calibri"/>
-              </a:rPr>
-              <a:t>3</a:t>
-            </a:r>
-          </a:p>
-        </p:txBody>
-      </p:sp>
-      <p:sp>
-        <p:nvSpPr>
-          <p:cNvPr id="18" name="TextBox 17"/>
+            <a:endParaRPr/>
+          </a:p>
+        </p:txBody>
+      </p:sp>
+      <p:sp>
+        <p:nvSpPr>
+          <p:cNvPr id="19" name="TextBox 18"/>
           <p:cNvSpPr txBox="1"/>
           <p:nvPr/>
         </p:nvSpPr>
         <p:spPr>
           <a:xfrm>
-            <a:off x="990600" y="3632200"/>
-            <a:ext cx="7620000" cy="228600"/>
+            <a:off x="571500" y="3962400"/>
+            <a:ext cx="8007400" cy="228600"/>
           </a:xfrm>
           <a:prstGeom prst="rect">
             <a:avLst/>
@@ -6293,27 +6733,27 @@
           <a:p>
             <a:pPr algn="l"/>
             <a:r>
-              <a:rPr sz="1200" b="1" i="0">
+              <a:rPr sz="1600" b="1">
                 <a:solidFill>
                   <a:srgbClr val="ADFF26"/>
                 </a:solidFill>
                 <a:latin typeface="Calibri"/>
               </a:rPr>
-              <a:t>Keep the toolkit current</a:t>
-            </a:r>
-          </a:p>
-        </p:txBody>
-      </p:sp>
-      <p:sp>
-        <p:nvSpPr>
-          <p:cNvPr id="19" name="TextBox 18"/>
+              <a:t>Focus on the hard 20%</a:t>
+            </a:r>
+          </a:p>
+        </p:txBody>
+      </p:sp>
+      <p:sp>
+        <p:nvSpPr>
+          <p:cNvPr id="20" name="TextBox 19"/>
           <p:cNvSpPr txBox="1"/>
           <p:nvPr/>
         </p:nvSpPr>
         <p:spPr>
           <a:xfrm>
-            <a:off x="990600" y="3886200"/>
-            <a:ext cx="7620000" cy="558800"/>
+            <a:off x="571500" y="4216400"/>
+            <a:ext cx="8007400" cy="330000"/>
           </a:xfrm>
           <a:prstGeom prst="rect">
             <a:avLst/>
@@ -6326,24 +6766,25 @@
           </a:bodyPr>
           <a:lstStyle/>
           <a:p>
-            <a:pPr algn="l">
-              <a:lnSpc>
-                <a:spcPct val="115000"/>
-              </a:lnSpc>
-            </a:pPr>
-            <a:r>
-              <a:rPr sz="1100" b="0" i="0">
+            <a:pPr algn="l"/>
+            <a:r>
+              <a:rPr sz="1100" b="0">
                 <a:solidFill>
                   <a:srgbClr val="FFFFFF"/>
                 </a:solidFill>
                 <a:latin typeface="Calibri"/>
               </a:rPr>
-              <a:t>Run databricks aitools update --scope project periodically — skills are CLI-managed, separate from this repo's version.</a:t>
+              <a:t>Spend your time on the architecture and decisions that actually need a human.</a:t>
             </a:r>
           </a:p>
         </p:txBody>
       </p:sp>
     </p:spTree>
+    <p:extLst>
+      <p:ext uri="{BB962C8B-B14F-4D97-AF65-F5344CB8AC3E}">
+        <p14:creationId xmlns:p14="http://schemas.microsoft.com/office/powerpoint/2010/main" val="2119589362"/>
+      </p:ext>
+    </p:extLst>
   </p:cSld>
   <p:clrMapOvr>
     <a:masterClrMapping/>
@@ -6383,7 +6824,7 @@
             <a:avLst/>
           </a:prstGeom>
           <a:solidFill>
-            <a:srgbClr val="222F2E"/>
+            <a:srgbClr val="F4F3EF"/>
           </a:solidFill>
           <a:ln>
             <a:noFill/>
@@ -6422,7 +6863,7 @@
         <p:spPr>
           <a:xfrm>
             <a:off x="0" y="0"/>
-            <a:ext cx="165100" cy="5143500"/>
+            <a:ext cx="114300" cy="5143500"/>
           </a:xfrm>
           <a:prstGeom prst="rect">
             <a:avLst/>
@@ -6458,9 +6899,124 @@
           </a:p>
         </p:txBody>
       </p:sp>
+      <p:sp>
+        <p:nvSpPr>
+          <p:cNvPr id="4" name="TextBox 3"/>
+          <p:cNvSpPr txBox="1"/>
+          <p:nvPr/>
+        </p:nvSpPr>
+        <p:spPr>
+          <a:xfrm>
+            <a:off x="368300" y="228600"/>
+            <a:ext cx="8407400" cy="406400"/>
+          </a:xfrm>
+          <a:prstGeom prst="rect">
+            <a:avLst/>
+          </a:prstGeom>
+          <a:noFill/>
+        </p:spPr>
+        <p:txBody>
+          <a:bodyPr wrap="square" lIns="0" tIns="0" rIns="0" bIns="0" anchor="t">
+            <a:spAutoFit/>
+          </a:bodyPr>
+          <a:lstStyle/>
+          <a:p>
+            <a:pPr algn="l"/>
+            <a:r>
+              <a:rPr sz="2400" b="1" i="0">
+                <a:solidFill>
+                  <a:srgbClr val="141712"/>
+                </a:solidFill>
+                <a:latin typeface="Calibri"/>
+              </a:rPr>
+              <a:t>Best Practices</a:t>
+            </a:r>
+          </a:p>
+        </p:txBody>
+      </p:sp>
+      <p:sp>
+        <p:nvSpPr>
+          <p:cNvPr id="5" name="TextBox 4"/>
+          <p:cNvSpPr txBox="1"/>
+          <p:nvPr/>
+        </p:nvSpPr>
+        <p:spPr>
+          <a:xfrm>
+            <a:off x="368300" y="698500"/>
+            <a:ext cx="5080000" cy="203200"/>
+          </a:xfrm>
+          <a:prstGeom prst="rect">
+            <a:avLst/>
+          </a:prstGeom>
+          <a:noFill/>
+        </p:spPr>
+        <p:txBody>
+          <a:bodyPr wrap="square" lIns="0" tIns="0" rIns="0" bIns="0" anchor="t">
+            <a:spAutoFit/>
+          </a:bodyPr>
+          <a:lstStyle/>
+          <a:p>
+            <a:pPr algn="l"/>
+            <a:r>
+              <a:rPr sz="1000" b="0" i="0">
+                <a:solidFill>
+                  <a:srgbClr val="77766E"/>
+                </a:solidFill>
+                <a:latin typeface="Calibri"/>
+              </a:rPr>
+              <a:t>02 / Install &amp; Configure</a:t>
+            </a:r>
+          </a:p>
+        </p:txBody>
+      </p:sp>
+      <p:sp>
+        <p:nvSpPr>
+          <p:cNvPr id="6" name="Rectangle 5"/>
+          <p:cNvSpPr/>
+          <p:nvPr/>
+        </p:nvSpPr>
+        <p:spPr>
+          <a:xfrm>
+            <a:off x="368300" y="965200"/>
+            <a:ext cx="8407400" cy="12700"/>
+          </a:xfrm>
+          <a:prstGeom prst="rect">
+            <a:avLst/>
+          </a:prstGeom>
+          <a:solidFill>
+            <a:srgbClr val="E3E2D9"/>
+          </a:solidFill>
+          <a:ln>
+            <a:noFill/>
+          </a:ln>
+          <a:effectLst/>
+        </p:spPr>
+        <p:style>
+          <a:lnRef idx="1">
+            <a:schemeClr val="accent1"/>
+          </a:lnRef>
+          <a:fillRef idx="3">
+            <a:schemeClr val="accent1"/>
+          </a:fillRef>
+          <a:effectRef idx="2">
+            <a:schemeClr val="accent1"/>
+          </a:effectRef>
+          <a:fontRef idx="minor">
+            <a:schemeClr val="lt1"/>
+          </a:fontRef>
+        </p:style>
+        <p:txBody>
+          <a:bodyPr rtlCol="0" anchor="ctr"/>
+          <a:lstStyle/>
+          <a:p>
+            <a:pPr algn="ctr"/>
+            <a:endParaRPr/>
+          </a:p>
+        </p:txBody>
+      </p:sp>
       <p:pic>
         <p:nvPicPr>
-          <p:cNvPr id="4" name="Picture 3" descr="origin-logo-04.png"/>
+          <p:cNvPr id="7" name="Picture 6" descr="origin-logo-02.png"/>
           <p:cNvPicPr>
             <a:picLocks noChangeAspect="1"/>
           </p:cNvPicPr>
@@ -6474,8 +7030,8 @@
         </p:blipFill>
         <p:spPr>
           <a:xfrm>
-            <a:off x="457200" y="457200"/>
-            <a:ext cx="1905000" cy="381000"/>
+            <a:off x="7137400" y="4749800"/>
+            <a:ext cx="1828800" cy="365760"/>
           </a:xfrm>
           <a:prstGeom prst="rect">
             <a:avLst/>
@@ -6484,14 +7040,112 @@
       </p:pic>
       <p:sp>
         <p:nvSpPr>
-          <p:cNvPr id="5" name="TextBox 4"/>
+          <p:cNvPr id="8" name="Rectangle 7"/>
+          <p:cNvSpPr/>
+          <p:nvPr/>
+        </p:nvSpPr>
+        <p:spPr>
+          <a:xfrm>
+            <a:off x="368300" y="1270000"/>
+            <a:ext cx="8407400" cy="990600"/>
+          </a:xfrm>
+          <a:prstGeom prst="rect">
+            <a:avLst/>
+          </a:prstGeom>
+          <a:solidFill>
+            <a:srgbClr val="141712"/>
+          </a:solidFill>
+          <a:ln>
+            <a:noFill/>
+          </a:ln>
+          <a:effectLst/>
+        </p:spPr>
+        <p:style>
+          <a:lnRef idx="1">
+            <a:schemeClr val="accent1"/>
+          </a:lnRef>
+          <a:fillRef idx="3">
+            <a:schemeClr val="accent1"/>
+          </a:fillRef>
+          <a:effectRef idx="2">
+            <a:schemeClr val="accent1"/>
+          </a:effectRef>
+          <a:fontRef idx="minor">
+            <a:schemeClr val="lt1"/>
+          </a:fontRef>
+        </p:style>
+        <p:txBody>
+          <a:bodyPr rtlCol="0" anchor="ctr"/>
+          <a:lstStyle/>
+          <a:p>
+            <a:pPr algn="ctr"/>
+            <a:endParaRPr/>
+          </a:p>
+        </p:txBody>
+      </p:sp>
+      <p:sp>
+        <p:nvSpPr>
+          <p:cNvPr id="9" name="Rounded Rectangle 8"/>
+          <p:cNvSpPr/>
+          <p:nvPr/>
+        </p:nvSpPr>
+        <p:spPr>
+          <a:xfrm>
+            <a:off x="368300" y="1562100"/>
+            <a:ext cx="406400" cy="406400"/>
+          </a:xfrm>
+          <a:prstGeom prst="roundRect">
+            <a:avLst/>
+          </a:prstGeom>
+          <a:solidFill>
+            <a:srgbClr val="ADFF26"/>
+          </a:solidFill>
+          <a:ln>
+            <a:noFill/>
+          </a:ln>
+          <a:effectLst/>
+        </p:spPr>
+        <p:style>
+          <a:lnRef idx="1">
+            <a:schemeClr val="accent1"/>
+          </a:lnRef>
+          <a:fillRef idx="3">
+            <a:schemeClr val="accent1"/>
+          </a:fillRef>
+          <a:effectRef idx="2">
+            <a:schemeClr val="accent1"/>
+          </a:effectRef>
+          <a:fontRef idx="minor">
+            <a:schemeClr val="lt1"/>
+          </a:fontRef>
+        </p:style>
+        <p:txBody>
+          <a:bodyPr rtlCol="0" anchor="ctr"/>
+          <a:lstStyle/>
+          <a:p>
+            <a:pPr algn="ctr"/>
+            <a:r>
+              <a:rPr sz="1400" b="1">
+                <a:solidFill>
+                  <a:srgbClr val="141712"/>
+                </a:solidFill>
+                <a:latin typeface="Calibri"/>
+              </a:rPr>
+              <a:t>1</a:t>
+            </a:r>
+          </a:p>
+        </p:txBody>
+      </p:sp>
+      <p:sp>
+        <p:nvSpPr>
+          <p:cNvPr id="10" name="TextBox 9"/>
           <p:cNvSpPr txBox="1"/>
           <p:nvPr/>
         </p:nvSpPr>
         <p:spPr>
           <a:xfrm>
-            <a:off x="0" y="1397000"/>
-            <a:ext cx="9144000" cy="2032000"/>
+            <a:off x="990600" y="1397000"/>
+            <a:ext cx="7620000" cy="228600"/>
           </a:xfrm>
           <a:prstGeom prst="rect">
             <a:avLst/>
@@ -6504,29 +7158,29 @@
           </a:bodyPr>
           <a:lstStyle/>
           <a:p>
-            <a:pPr algn="ctr"/>
-            <a:r>
-              <a:rPr sz="14000" b="1" i="0">
+            <a:pPr algn="l"/>
+            <a:r>
+              <a:rPr sz="1200" b="1" i="0">
                 <a:solidFill>
                   <a:srgbClr val="ADFF26"/>
                 </a:solidFill>
                 <a:latin typeface="Calibri"/>
               </a:rPr>
-              <a:t>DEMO</a:t>
-            </a:r>
-          </a:p>
-        </p:txBody>
-      </p:sp>
-      <p:sp>
-        <p:nvSpPr>
-          <p:cNvPr id="6" name="TextBox 5"/>
+              <a:t>Curate which skills auto-trigger</a:t>
+            </a:r>
+          </a:p>
+        </p:txBody>
+      </p:sp>
+      <p:sp>
+        <p:nvSpPr>
+          <p:cNvPr id="11" name="TextBox 10"/>
           <p:cNvSpPr txBox="1"/>
           <p:nvPr/>
         </p:nvSpPr>
         <p:spPr>
           <a:xfrm>
-            <a:off x="762000" y="3556000"/>
-            <a:ext cx="7620000" cy="381000"/>
+            <a:off x="990600" y="1651000"/>
+            <a:ext cx="7620000" cy="558800"/>
           </a:xfrm>
           <a:prstGeom prst="rect">
             <a:avLst/>
@@ -6539,29 +7193,275 @@
           </a:bodyPr>
           <a:lstStyle/>
           <a:p>
-            <a:pPr algn="ctr"/>
-            <a:r>
-              <a:rPr sz="1600" b="0" i="0">
+            <a:pPr algn="l">
+              <a:lnSpc>
+                <a:spcPct val="115000"/>
+              </a:lnSpc>
+            </a:pPr>
+            <a:r>
+              <a:rPr sz="1100" b="0" i="0" dirty="0">
                 <a:solidFill>
                   <a:srgbClr val="FFFFFF"/>
                 </a:solidFill>
                 <a:latin typeface="Calibri"/>
               </a:rPr>
-              <a:t>Building a real Databricks Asset Bundle, live, with AI.</a:t>
-            </a:r>
-          </a:p>
-        </p:txBody>
-      </p:sp>
-      <p:sp>
-        <p:nvSpPr>
-          <p:cNvPr id="7" name="TextBox 6"/>
+              <a:t>Avoid skill sprawl: set most </a:t>
+            </a:r>
+            <a:r>
+              <a:rPr sz="1100" b="0" i="0" dirty="0" err="1">
+                <a:solidFill>
+                  <a:srgbClr val="FFFFFF"/>
+                </a:solidFill>
+                <a:latin typeface="Calibri"/>
+              </a:rPr>
+              <a:t>databricks</a:t>
+            </a:r>
+            <a:r>
+              <a:rPr sz="1100" b="0" i="0" dirty="0">
+                <a:solidFill>
+                  <a:srgbClr val="FFFFFF"/>
+                </a:solidFill>
+                <a:latin typeface="Calibri"/>
+              </a:rPr>
+              <a:t>-* skills to "user-invokable-only" in .</a:t>
+            </a:r>
+            <a:r>
+              <a:rPr sz="1100" b="0" i="0" dirty="0" err="1">
+                <a:solidFill>
+                  <a:srgbClr val="FFFFFF"/>
+                </a:solidFill>
+                <a:latin typeface="Calibri"/>
+              </a:rPr>
+              <a:t>claude</a:t>
+            </a:r>
+            <a:r>
+              <a:rPr sz="1100" b="0" i="0" dirty="0">
+                <a:solidFill>
+                  <a:srgbClr val="FFFFFF"/>
+                </a:solidFill>
+                <a:latin typeface="Calibri"/>
+              </a:rPr>
+              <a:t>/</a:t>
+            </a:r>
+            <a:r>
+              <a:rPr sz="1100" b="0" i="0" dirty="0" err="1">
+                <a:solidFill>
+                  <a:srgbClr val="FFFFFF"/>
+                </a:solidFill>
+                <a:latin typeface="Calibri"/>
+              </a:rPr>
+              <a:t>settings.local.json</a:t>
+            </a:r>
+            <a:r>
+              <a:rPr sz="1100" b="0" i="0" dirty="0">
+                <a:solidFill>
+                  <a:srgbClr val="FFFFFF"/>
+                </a:solidFill>
+                <a:latin typeface="Calibri"/>
+              </a:rPr>
+              <a:t> — keep </a:t>
+            </a:r>
+            <a:r>
+              <a:rPr sz="1100" b="0" i="0" dirty="0" err="1">
+                <a:solidFill>
+                  <a:srgbClr val="FFFFFF"/>
+                </a:solidFill>
+                <a:latin typeface="Calibri"/>
+              </a:rPr>
+              <a:t>databricks</a:t>
+            </a:r>
+            <a:r>
+              <a:rPr sz="1100" b="0" i="0" dirty="0">
+                <a:solidFill>
+                  <a:srgbClr val="FFFFFF"/>
+                </a:solidFill>
+                <a:latin typeface="Calibri"/>
+              </a:rPr>
+              <a:t>-core, </a:t>
+            </a:r>
+            <a:r>
+              <a:rPr sz="1100" b="0" i="0" dirty="0" err="1">
+                <a:solidFill>
+                  <a:srgbClr val="FFFFFF"/>
+                </a:solidFill>
+                <a:latin typeface="Calibri"/>
+              </a:rPr>
+              <a:t>databricks</a:t>
+            </a:r>
+            <a:r>
+              <a:rPr sz="1100" b="0" i="0" dirty="0">
+                <a:solidFill>
+                  <a:srgbClr val="FFFFFF"/>
+                </a:solidFill>
+                <a:latin typeface="Calibri"/>
+              </a:rPr>
+              <a:t>-docs, </a:t>
+            </a:r>
+            <a:r>
+              <a:rPr sz="1100" b="0" i="0" dirty="0" err="1">
+                <a:solidFill>
+                  <a:srgbClr val="FFFFFF"/>
+                </a:solidFill>
+                <a:latin typeface="Calibri"/>
+              </a:rPr>
+              <a:t>databricks</a:t>
+            </a:r>
+            <a:r>
+              <a:rPr sz="1100" b="0" i="0" dirty="0">
+                <a:solidFill>
+                  <a:srgbClr val="FFFFFF"/>
+                </a:solidFill>
+                <a:latin typeface="Calibri"/>
+              </a:rPr>
+              <a:t>-python-</a:t>
+            </a:r>
+            <a:r>
+              <a:rPr sz="1100" b="0" i="0" dirty="0" err="1">
+                <a:solidFill>
+                  <a:srgbClr val="FFFFFF"/>
+                </a:solidFill>
+                <a:latin typeface="Calibri"/>
+              </a:rPr>
+              <a:t>sdk</a:t>
+            </a:r>
+            <a:r>
+              <a:rPr sz="1100" b="0" i="0" dirty="0">
+                <a:solidFill>
+                  <a:srgbClr val="FFFFFF"/>
+                </a:solidFill>
+                <a:latin typeface="Calibri"/>
+              </a:rPr>
+              <a:t>, and </a:t>
+            </a:r>
+            <a:r>
+              <a:rPr sz="1100" b="0" i="0" dirty="0" err="1">
+                <a:solidFill>
+                  <a:srgbClr val="FFFFFF"/>
+                </a:solidFill>
+                <a:latin typeface="Calibri"/>
+              </a:rPr>
+              <a:t>databricks</a:t>
+            </a:r>
+            <a:r>
+              <a:rPr sz="1100" b="0" i="0" dirty="0">
+                <a:solidFill>
+                  <a:srgbClr val="FFFFFF"/>
+                </a:solidFill>
+                <a:latin typeface="Calibri"/>
+              </a:rPr>
+              <a:t>-unity-catalog "on".</a:t>
+            </a:r>
+          </a:p>
+        </p:txBody>
+      </p:sp>
+      <p:sp>
+        <p:nvSpPr>
+          <p:cNvPr id="12" name="Rectangle 11"/>
+          <p:cNvSpPr/>
+          <p:nvPr/>
+        </p:nvSpPr>
+        <p:spPr>
+          <a:xfrm>
+            <a:off x="368300" y="2387600"/>
+            <a:ext cx="8407400" cy="990600"/>
+          </a:xfrm>
+          <a:prstGeom prst="rect">
+            <a:avLst/>
+          </a:prstGeom>
+          <a:solidFill>
+            <a:srgbClr val="141712"/>
+          </a:solidFill>
+          <a:ln>
+            <a:noFill/>
+          </a:ln>
+          <a:effectLst/>
+        </p:spPr>
+        <p:style>
+          <a:lnRef idx="1">
+            <a:schemeClr val="accent1"/>
+          </a:lnRef>
+          <a:fillRef idx="3">
+            <a:schemeClr val="accent1"/>
+          </a:fillRef>
+          <a:effectRef idx="2">
+            <a:schemeClr val="accent1"/>
+          </a:effectRef>
+          <a:fontRef idx="minor">
+            <a:schemeClr val="lt1"/>
+          </a:fontRef>
+        </p:style>
+        <p:txBody>
+          <a:bodyPr rtlCol="0" anchor="ctr"/>
+          <a:lstStyle/>
+          <a:p>
+            <a:pPr algn="ctr"/>
+            <a:endParaRPr/>
+          </a:p>
+        </p:txBody>
+      </p:sp>
+      <p:sp>
+        <p:nvSpPr>
+          <p:cNvPr id="13" name="Rounded Rectangle 12"/>
+          <p:cNvSpPr/>
+          <p:nvPr/>
+        </p:nvSpPr>
+        <p:spPr>
+          <a:xfrm>
+            <a:off x="368300" y="2679700"/>
+            <a:ext cx="406400" cy="406400"/>
+          </a:xfrm>
+          <a:prstGeom prst="roundRect">
+            <a:avLst/>
+          </a:prstGeom>
+          <a:solidFill>
+            <a:srgbClr val="ADFF26"/>
+          </a:solidFill>
+          <a:ln>
+            <a:noFill/>
+          </a:ln>
+          <a:effectLst/>
+        </p:spPr>
+        <p:style>
+          <a:lnRef idx="1">
+            <a:schemeClr val="accent1"/>
+          </a:lnRef>
+          <a:fillRef idx="3">
+            <a:schemeClr val="accent1"/>
+          </a:fillRef>
+          <a:effectRef idx="2">
+            <a:schemeClr val="accent1"/>
+          </a:effectRef>
+          <a:fontRef idx="minor">
+            <a:schemeClr val="lt1"/>
+          </a:fontRef>
+        </p:style>
+        <p:txBody>
+          <a:bodyPr rtlCol="0" anchor="ctr"/>
+          <a:lstStyle/>
+          <a:p>
+            <a:pPr algn="ctr"/>
+            <a:r>
+              <a:rPr sz="1400" b="1">
+                <a:solidFill>
+                  <a:srgbClr val="141712"/>
+                </a:solidFill>
+                <a:latin typeface="Calibri"/>
+              </a:rPr>
+              <a:t>2</a:t>
+            </a:r>
+          </a:p>
+        </p:txBody>
+      </p:sp>
+      <p:sp>
+        <p:nvSpPr>
+          <p:cNvPr id="14" name="TextBox 13"/>
           <p:cNvSpPr txBox="1"/>
           <p:nvPr/>
         </p:nvSpPr>
         <p:spPr>
           <a:xfrm>
-            <a:off x="762000" y="4000500"/>
-            <a:ext cx="7620000" cy="254000"/>
+            <a:off x="990600" y="2514600"/>
+            <a:ext cx="7620000" cy="228600"/>
           </a:xfrm>
           <a:prstGeom prst="rect">
             <a:avLst/>
@@ -6574,15 +7474,226 @@
           </a:bodyPr>
           <a:lstStyle/>
           <a:p>
-            <a:pPr algn="ctr"/>
-            <a:r>
-              <a:rPr sz="1100" b="0" i="1">
-                <a:solidFill>
-                  <a:srgbClr val="9B9B9B"/>
+            <a:pPr algn="l"/>
+            <a:r>
+              <a:rPr sz="1200" b="1" i="0">
+                <a:solidFill>
+                  <a:srgbClr val="ADFF26"/>
                 </a:solidFill>
                 <a:latin typeface="Calibri"/>
               </a:rPr>
-              <a:t>(Using the Wanderbricks sample dataset.)</a:t>
+              <a:t>Reload after config changes</a:t>
+            </a:r>
+          </a:p>
+        </p:txBody>
+      </p:sp>
+      <p:sp>
+        <p:nvSpPr>
+          <p:cNvPr id="15" name="TextBox 14"/>
+          <p:cNvSpPr txBox="1"/>
+          <p:nvPr/>
+        </p:nvSpPr>
+        <p:spPr>
+          <a:xfrm>
+            <a:off x="990600" y="2768600"/>
+            <a:ext cx="7620000" cy="558800"/>
+          </a:xfrm>
+          <a:prstGeom prst="rect">
+            <a:avLst/>
+          </a:prstGeom>
+          <a:noFill/>
+        </p:spPr>
+        <p:txBody>
+          <a:bodyPr wrap="square" lIns="0" tIns="0" rIns="0" bIns="0" anchor="t">
+            <a:spAutoFit/>
+          </a:bodyPr>
+          <a:lstStyle/>
+          <a:p>
+            <a:pPr algn="l">
+              <a:lnSpc>
+                <a:spcPct val="115000"/>
+              </a:lnSpc>
+            </a:pPr>
+            <a:r>
+              <a:rPr sz="1100" b="0" i="0">
+                <a:solidFill>
+                  <a:srgbClr val="FFFFFF"/>
+                </a:solidFill>
+                <a:latin typeface="Calibri"/>
+              </a:rPr>
+              <a:t>Run /reload-skills so the agent picks up new skill overrides right away.</a:t>
+            </a:r>
+          </a:p>
+        </p:txBody>
+      </p:sp>
+      <p:sp>
+        <p:nvSpPr>
+          <p:cNvPr id="16" name="Rectangle 15"/>
+          <p:cNvSpPr/>
+          <p:nvPr/>
+        </p:nvSpPr>
+        <p:spPr>
+          <a:xfrm>
+            <a:off x="368300" y="3505200"/>
+            <a:ext cx="8407400" cy="990600"/>
+          </a:xfrm>
+          <a:prstGeom prst="rect">
+            <a:avLst/>
+          </a:prstGeom>
+          <a:solidFill>
+            <a:srgbClr val="141712"/>
+          </a:solidFill>
+          <a:ln>
+            <a:noFill/>
+          </a:ln>
+          <a:effectLst/>
+        </p:spPr>
+        <p:style>
+          <a:lnRef idx="1">
+            <a:schemeClr val="accent1"/>
+          </a:lnRef>
+          <a:fillRef idx="3">
+            <a:schemeClr val="accent1"/>
+          </a:fillRef>
+          <a:effectRef idx="2">
+            <a:schemeClr val="accent1"/>
+          </a:effectRef>
+          <a:fontRef idx="minor">
+            <a:schemeClr val="lt1"/>
+          </a:fontRef>
+        </p:style>
+        <p:txBody>
+          <a:bodyPr rtlCol="0" anchor="ctr"/>
+          <a:lstStyle/>
+          <a:p>
+            <a:pPr algn="ctr"/>
+            <a:endParaRPr/>
+          </a:p>
+        </p:txBody>
+      </p:sp>
+      <p:sp>
+        <p:nvSpPr>
+          <p:cNvPr id="17" name="Rounded Rectangle 16"/>
+          <p:cNvSpPr/>
+          <p:nvPr/>
+        </p:nvSpPr>
+        <p:spPr>
+          <a:xfrm>
+            <a:off x="368300" y="3797300"/>
+            <a:ext cx="406400" cy="406400"/>
+          </a:xfrm>
+          <a:prstGeom prst="roundRect">
+            <a:avLst/>
+          </a:prstGeom>
+          <a:solidFill>
+            <a:srgbClr val="ADFF26"/>
+          </a:solidFill>
+          <a:ln>
+            <a:noFill/>
+          </a:ln>
+          <a:effectLst/>
+        </p:spPr>
+        <p:style>
+          <a:lnRef idx="1">
+            <a:schemeClr val="accent1"/>
+          </a:lnRef>
+          <a:fillRef idx="3">
+            <a:schemeClr val="accent1"/>
+          </a:fillRef>
+          <a:effectRef idx="2">
+            <a:schemeClr val="accent1"/>
+          </a:effectRef>
+          <a:fontRef idx="minor">
+            <a:schemeClr val="lt1"/>
+          </a:fontRef>
+        </p:style>
+        <p:txBody>
+          <a:bodyPr rtlCol="0" anchor="ctr"/>
+          <a:lstStyle/>
+          <a:p>
+            <a:pPr algn="ctr"/>
+            <a:r>
+              <a:rPr sz="1400" b="1">
+                <a:solidFill>
+                  <a:srgbClr val="141712"/>
+                </a:solidFill>
+                <a:latin typeface="Calibri"/>
+              </a:rPr>
+              <a:t>3</a:t>
+            </a:r>
+          </a:p>
+        </p:txBody>
+      </p:sp>
+      <p:sp>
+        <p:nvSpPr>
+          <p:cNvPr id="18" name="TextBox 17"/>
+          <p:cNvSpPr txBox="1"/>
+          <p:nvPr/>
+        </p:nvSpPr>
+        <p:spPr>
+          <a:xfrm>
+            <a:off x="990600" y="3632200"/>
+            <a:ext cx="7620000" cy="228600"/>
+          </a:xfrm>
+          <a:prstGeom prst="rect">
+            <a:avLst/>
+          </a:prstGeom>
+          <a:noFill/>
+        </p:spPr>
+        <p:txBody>
+          <a:bodyPr wrap="square" lIns="0" tIns="0" rIns="0" bIns="0" anchor="t">
+            <a:spAutoFit/>
+          </a:bodyPr>
+          <a:lstStyle/>
+          <a:p>
+            <a:pPr algn="l"/>
+            <a:r>
+              <a:rPr sz="1200" b="1" i="0">
+                <a:solidFill>
+                  <a:srgbClr val="ADFF26"/>
+                </a:solidFill>
+                <a:latin typeface="Calibri"/>
+              </a:rPr>
+              <a:t>Keep the toolkit current</a:t>
+            </a:r>
+          </a:p>
+        </p:txBody>
+      </p:sp>
+      <p:sp>
+        <p:nvSpPr>
+          <p:cNvPr id="19" name="TextBox 18"/>
+          <p:cNvSpPr txBox="1"/>
+          <p:nvPr/>
+        </p:nvSpPr>
+        <p:spPr>
+          <a:xfrm>
+            <a:off x="990600" y="3886200"/>
+            <a:ext cx="7620000" cy="558800"/>
+          </a:xfrm>
+          <a:prstGeom prst="rect">
+            <a:avLst/>
+          </a:prstGeom>
+          <a:noFill/>
+        </p:spPr>
+        <p:txBody>
+          <a:bodyPr wrap="square" lIns="0" tIns="0" rIns="0" bIns="0" anchor="t">
+            <a:spAutoFit/>
+          </a:bodyPr>
+          <a:lstStyle/>
+          <a:p>
+            <a:pPr algn="l">
+              <a:lnSpc>
+                <a:spcPct val="115000"/>
+              </a:lnSpc>
+            </a:pPr>
+            <a:r>
+              <a:rPr sz="1100" b="0" i="0">
+                <a:solidFill>
+                  <a:srgbClr val="FFFFFF"/>
+                </a:solidFill>
+                <a:latin typeface="Calibri"/>
+              </a:rPr>
+              <a:t>Run databricks aitools update --scope project periodically — skills are CLI-managed, separate from this repo's version.</a:t>
             </a:r>
           </a:p>
         </p:txBody>
@@ -6596,6 +7707,250 @@
 </file>
 
 <file path=ppt/slides/slide6.xml><?xml version="1.0" encoding="utf-8"?>
+<p:sld xmlns:a="http://schemas.openxmlformats.org/drawingml/2006/main" xmlns:r="http://schemas.openxmlformats.org/officeDocument/2006/relationships" xmlns:p="http://schemas.openxmlformats.org/presentationml/2006/main">
+  <p:cSld>
+    <p:spTree>
+      <p:nvGrpSpPr>
+        <p:cNvPr id="1" name=""/>
+        <p:cNvGrpSpPr/>
+        <p:nvPr/>
+      </p:nvGrpSpPr>
+      <p:grpSpPr>
+        <a:xfrm>
+          <a:off x="0" y="0"/>
+          <a:ext cx="0" cy="0"/>
+          <a:chOff x="0" y="0"/>
+          <a:chExt cx="0" cy="0"/>
+        </a:xfrm>
+      </p:grpSpPr>
+      <p:sp>
+        <p:nvSpPr>
+          <p:cNvPr id="2" name="Rectangle 1"/>
+          <p:cNvSpPr/>
+          <p:nvPr/>
+        </p:nvSpPr>
+        <p:spPr>
+          <a:xfrm>
+            <a:off x="0" y="0"/>
+            <a:ext cx="9144000" cy="5143500"/>
+          </a:xfrm>
+          <a:prstGeom prst="rect">
+            <a:avLst/>
+          </a:prstGeom>
+          <a:solidFill>
+            <a:srgbClr val="222F2E"/>
+          </a:solidFill>
+          <a:ln>
+            <a:noFill/>
+          </a:ln>
+          <a:effectLst/>
+        </p:spPr>
+        <p:style>
+          <a:lnRef idx="1">
+            <a:schemeClr val="accent1"/>
+          </a:lnRef>
+          <a:fillRef idx="3">
+            <a:schemeClr val="accent1"/>
+          </a:fillRef>
+          <a:effectRef idx="2">
+            <a:schemeClr val="accent1"/>
+          </a:effectRef>
+          <a:fontRef idx="minor">
+            <a:schemeClr val="lt1"/>
+          </a:fontRef>
+        </p:style>
+        <p:txBody>
+          <a:bodyPr rtlCol="0" anchor="ctr"/>
+          <a:lstStyle/>
+          <a:p>
+            <a:pPr algn="ctr"/>
+            <a:endParaRPr/>
+          </a:p>
+        </p:txBody>
+      </p:sp>
+      <p:sp>
+        <p:nvSpPr>
+          <p:cNvPr id="3" name="Rectangle 2"/>
+          <p:cNvSpPr/>
+          <p:nvPr/>
+        </p:nvSpPr>
+        <p:spPr>
+          <a:xfrm>
+            <a:off x="0" y="0"/>
+            <a:ext cx="165100" cy="5143500"/>
+          </a:xfrm>
+          <a:prstGeom prst="rect">
+            <a:avLst/>
+          </a:prstGeom>
+          <a:solidFill>
+            <a:srgbClr val="ADFF26"/>
+          </a:solidFill>
+          <a:ln>
+            <a:noFill/>
+          </a:ln>
+          <a:effectLst/>
+        </p:spPr>
+        <p:style>
+          <a:lnRef idx="1">
+            <a:schemeClr val="accent1"/>
+          </a:lnRef>
+          <a:fillRef idx="3">
+            <a:schemeClr val="accent1"/>
+          </a:fillRef>
+          <a:effectRef idx="2">
+            <a:schemeClr val="accent1"/>
+          </a:effectRef>
+          <a:fontRef idx="minor">
+            <a:schemeClr val="lt1"/>
+          </a:fontRef>
+        </p:style>
+        <p:txBody>
+          <a:bodyPr rtlCol="0" anchor="ctr"/>
+          <a:lstStyle/>
+          <a:p>
+            <a:pPr algn="ctr"/>
+            <a:endParaRPr/>
+          </a:p>
+        </p:txBody>
+      </p:sp>
+      <p:pic>
+        <p:nvPicPr>
+          <p:cNvPr id="4" name="Picture 3" descr="origin-logo-04.png"/>
+          <p:cNvPicPr>
+            <a:picLocks noChangeAspect="1"/>
+          </p:cNvPicPr>
+          <p:nvPr/>
+        </p:nvPicPr>
+        <p:blipFill>
+          <a:blip r:embed="rId2"/>
+          <a:stretch>
+            <a:fillRect/>
+          </a:stretch>
+        </p:blipFill>
+        <p:spPr>
+          <a:xfrm>
+            <a:off x="457200" y="457200"/>
+            <a:ext cx="1905000" cy="381000"/>
+          </a:xfrm>
+          <a:prstGeom prst="rect">
+            <a:avLst/>
+          </a:prstGeom>
+        </p:spPr>
+      </p:pic>
+      <p:sp>
+        <p:nvSpPr>
+          <p:cNvPr id="5" name="TextBox 4"/>
+          <p:cNvSpPr txBox="1"/>
+          <p:nvPr/>
+        </p:nvSpPr>
+        <p:spPr>
+          <a:xfrm>
+            <a:off x="0" y="1397000"/>
+            <a:ext cx="9144000" cy="2032000"/>
+          </a:xfrm>
+          <a:prstGeom prst="rect">
+            <a:avLst/>
+          </a:prstGeom>
+          <a:noFill/>
+        </p:spPr>
+        <p:txBody>
+          <a:bodyPr wrap="square" lIns="0" tIns="0" rIns="0" bIns="0" anchor="t">
+            <a:spAutoFit/>
+          </a:bodyPr>
+          <a:lstStyle/>
+          <a:p>
+            <a:pPr algn="ctr"/>
+            <a:r>
+              <a:rPr sz="14000" b="1" i="0">
+                <a:solidFill>
+                  <a:srgbClr val="ADFF26"/>
+                </a:solidFill>
+                <a:latin typeface="Calibri"/>
+              </a:rPr>
+              <a:t>DEMO</a:t>
+            </a:r>
+          </a:p>
+        </p:txBody>
+      </p:sp>
+      <p:sp>
+        <p:nvSpPr>
+          <p:cNvPr id="6" name="TextBox 5"/>
+          <p:cNvSpPr txBox="1"/>
+          <p:nvPr/>
+        </p:nvSpPr>
+        <p:spPr>
+          <a:xfrm>
+            <a:off x="762000" y="3556000"/>
+            <a:ext cx="7620000" cy="381000"/>
+          </a:xfrm>
+          <a:prstGeom prst="rect">
+            <a:avLst/>
+          </a:prstGeom>
+          <a:noFill/>
+        </p:spPr>
+        <p:txBody>
+          <a:bodyPr wrap="square" lIns="0" tIns="0" rIns="0" bIns="0" anchor="t">
+            <a:spAutoFit/>
+          </a:bodyPr>
+          <a:lstStyle/>
+          <a:p>
+            <a:pPr algn="ctr"/>
+            <a:r>
+              <a:rPr sz="1600" b="0" i="0">
+                <a:solidFill>
+                  <a:srgbClr val="FFFFFF"/>
+                </a:solidFill>
+                <a:latin typeface="Calibri"/>
+              </a:rPr>
+              <a:t>Building a real Databricks Asset Bundle, live, with AI.</a:t>
+            </a:r>
+          </a:p>
+        </p:txBody>
+      </p:sp>
+      <p:sp>
+        <p:nvSpPr>
+          <p:cNvPr id="7" name="TextBox 6"/>
+          <p:cNvSpPr txBox="1"/>
+          <p:nvPr/>
+        </p:nvSpPr>
+        <p:spPr>
+          <a:xfrm>
+            <a:off x="762000" y="4000500"/>
+            <a:ext cx="7620000" cy="254000"/>
+          </a:xfrm>
+          <a:prstGeom prst="rect">
+            <a:avLst/>
+          </a:prstGeom>
+          <a:noFill/>
+        </p:spPr>
+        <p:txBody>
+          <a:bodyPr wrap="square" lIns="0" tIns="0" rIns="0" bIns="0" anchor="t">
+            <a:spAutoFit/>
+          </a:bodyPr>
+          <a:lstStyle/>
+          <a:p>
+            <a:pPr algn="ctr"/>
+            <a:r>
+              <a:rPr sz="1100" b="0" i="1">
+                <a:solidFill>
+                  <a:srgbClr val="9B9B9B"/>
+                </a:solidFill>
+                <a:latin typeface="Calibri"/>
+              </a:rPr>
+              <a:t>(Using the Wanderbricks sample dataset.)</a:t>
+            </a:r>
+          </a:p>
+        </p:txBody>
+      </p:sp>
+    </p:spTree>
+  </p:cSld>
+  <p:clrMapOvr>
+    <a:masterClrMapping/>
+  </p:clrMapOvr>
+</p:sld>
+</file>
+
+<file path=ppt/slides/slide7.xml><?xml version="1.0" encoding="utf-8"?>
 <p:sld xmlns:a="http://schemas.openxmlformats.org/drawingml/2006/main" xmlns:r="http://schemas.openxmlformats.org/officeDocument/2006/relationships" xmlns:p="http://schemas.openxmlformats.org/presentationml/2006/main">
   <p:cSld>
     <p:spTree>
@@ -7450,4 +8805,319 @@
   </a:objectDefaults>
   <a:extraClrSchemeLst/>
 </a:theme>
+</file>
+
+<file path=ppt/theme/theme2.xml><?xml version="1.0" encoding="utf-8"?>
+<a:theme xmlns:a="http://schemas.openxmlformats.org/drawingml/2006/main" name="Office Theme">
+  <a:themeElements>
+    <a:clrScheme name="Office">
+      <a:dk1>
+        <a:sysClr val="windowText" lastClr="000000"/>
+      </a:dk1>
+      <a:lt1>
+        <a:sysClr val="window" lastClr="FFFFFF"/>
+      </a:lt1>
+      <a:dk2>
+        <a:srgbClr val="0E2841"/>
+      </a:dk2>
+      <a:lt2>
+        <a:srgbClr val="E8E8E8"/>
+      </a:lt2>
+      <a:accent1>
+        <a:srgbClr val="156082"/>
+      </a:accent1>
+      <a:accent2>
+        <a:srgbClr val="E97132"/>
+      </a:accent2>
+      <a:accent3>
+        <a:srgbClr val="196B24"/>
+      </a:accent3>
+      <a:accent4>
+        <a:srgbClr val="0F9ED5"/>
+      </a:accent4>
+      <a:accent5>
+        <a:srgbClr val="A02B93"/>
+      </a:accent5>
+      <a:accent6>
+        <a:srgbClr val="4EA72E"/>
+      </a:accent6>
+      <a:hlink>
+        <a:srgbClr val="467886"/>
+      </a:hlink>
+      <a:folHlink>
+        <a:srgbClr val="96607D"/>
+      </a:folHlink>
+    </a:clrScheme>
+    <a:fontScheme name="Office">
+      <a:majorFont>
+        <a:latin typeface="Aptos Display" panose="02110004020202020204"/>
+        <a:ea typeface=""/>
+        <a:cs typeface=""/>
+        <a:font script="Jpan" typeface="游ゴシック Light"/>
+        <a:font script="Hang" typeface="맑은 고딕"/>
+        <a:font script="Hans" typeface="等线 Light"/>
+        <a:font script="Hant" typeface="新細明體"/>
+        <a:font script="Arab" typeface="Times New Roman"/>
+        <a:font script="Hebr" typeface="Times New Roman"/>
+        <a:font script="Thai" typeface="Angsana New"/>
+        <a:font script="Ethi" typeface="Nyala"/>
+        <a:font script="Beng" typeface="Vrinda"/>
+        <a:font script="Gujr" typeface="Shruti"/>
+        <a:font script="Khmr" typeface="MoolBoran"/>
+        <a:font script="Knda" typeface="Tunga"/>
+        <a:font script="Guru" typeface="Raavi"/>
+        <a:font script="Cans" typeface="Euphemia"/>
+        <a:font script="Cher" typeface="Plantagenet Cherokee"/>
+        <a:font script="Yiii" typeface="Microsoft Yi Baiti"/>
+        <a:font script="Tibt" typeface="Microsoft Himalaya"/>
+        <a:font script="Thaa" typeface="MV Boli"/>
+        <a:font script="Deva" typeface="Mangal"/>
+        <a:font script="Telu" typeface="Gautami"/>
+        <a:font script="Taml" typeface="Latha"/>
+        <a:font script="Syrc" typeface="Estrangelo Edessa"/>
+        <a:font script="Orya" typeface="Kalinga"/>
+        <a:font script="Mlym" typeface="Kartika"/>
+        <a:font script="Laoo" typeface="DokChampa"/>
+        <a:font script="Sinh" typeface="Iskoola Pota"/>
+        <a:font script="Mong" typeface="Mongolian Baiti"/>
+        <a:font script="Viet" typeface="Times New Roman"/>
+        <a:font script="Uigh" typeface="Microsoft Uighur"/>
+        <a:font script="Geor" typeface="Sylfaen"/>
+        <a:font script="Armn" typeface="Arial"/>
+        <a:font script="Bugi" typeface="Leelawadee UI"/>
+        <a:font script="Bopo" typeface="Microsoft JhengHei"/>
+        <a:font script="Java" typeface="Javanese Text"/>
+        <a:font script="Lisu" typeface="Segoe UI"/>
+        <a:font script="Mymr" typeface="Myanmar Text"/>
+        <a:font script="Nkoo" typeface="Ebrima"/>
+        <a:font script="Olck" typeface="Nirmala UI"/>
+        <a:font script="Osma" typeface="Ebrima"/>
+        <a:font script="Phag" typeface="Phagspa"/>
+        <a:font script="Syrn" typeface="Estrangelo Edessa"/>
+        <a:font script="Syrj" typeface="Estrangelo Edessa"/>
+        <a:font script="Syre" typeface="Estrangelo Edessa"/>
+        <a:font script="Sora" typeface="Nirmala UI"/>
+        <a:font script="Tale" typeface="Microsoft Tai Le"/>
+        <a:font script="Talu" typeface="Microsoft New Tai Lue"/>
+        <a:font script="Tfng" typeface="Ebrima"/>
+      </a:majorFont>
+      <a:minorFont>
+        <a:latin typeface="Aptos" panose="02110004020202020204"/>
+        <a:ea typeface=""/>
+        <a:cs typeface=""/>
+        <a:font script="Jpan" typeface="游ゴシック"/>
+        <a:font script="Hang" typeface="맑은 고딕"/>
+        <a:font script="Hans" typeface="等线"/>
+        <a:font script="Hant" typeface="新細明體"/>
+        <a:font script="Arab" typeface="Arial"/>
+        <a:font script="Hebr" typeface="Arial"/>
+        <a:font script="Thai" typeface="Cordia New"/>
+        <a:font script="Ethi" typeface="Nyala"/>
+        <a:font script="Beng" typeface="Vrinda"/>
+        <a:font script="Gujr" typeface="Shruti"/>
+        <a:font script="Khmr" typeface="DaunPenh"/>
+        <a:font script="Knda" typeface="Tunga"/>
+        <a:font script="Guru" typeface="Raavi"/>
+        <a:font script="Cans" typeface="Euphemia"/>
+        <a:font script="Cher" typeface="Plantagenet Cherokee"/>
+        <a:font script="Yiii" typeface="Microsoft Yi Baiti"/>
+        <a:font script="Tibt" typeface="Microsoft Himalaya"/>
+        <a:font script="Thaa" typeface="MV Boli"/>
+        <a:font script="Deva" typeface="Mangal"/>
+        <a:font script="Telu" typeface="Gautami"/>
+        <a:font script="Taml" typeface="Latha"/>
+        <a:font script="Syrc" typeface="Estrangelo Edessa"/>
+        <a:font script="Orya" typeface="Kalinga"/>
+        <a:font script="Mlym" typeface="Kartika"/>
+        <a:font script="Laoo" typeface="DokChampa"/>
+        <a:font script="Sinh" typeface="Iskoola Pota"/>
+        <a:font script="Mong" typeface="Mongolian Baiti"/>
+        <a:font script="Viet" typeface="Arial"/>
+        <a:font script="Uigh" typeface="Microsoft Uighur"/>
+        <a:font script="Geor" typeface="Sylfaen"/>
+        <a:font script="Armn" typeface="Arial"/>
+        <a:font script="Bugi" typeface="Leelawadee UI"/>
+        <a:font script="Bopo" typeface="Microsoft JhengHei"/>
+        <a:font script="Java" typeface="Javanese Text"/>
+        <a:font script="Lisu" typeface="Segoe UI"/>
+        <a:font script="Mymr" typeface="Myanmar Text"/>
+        <a:font script="Nkoo" typeface="Ebrima"/>
+        <a:font script="Olck" typeface="Nirmala UI"/>
+        <a:font script="Osma" typeface="Ebrima"/>
+        <a:font script="Phag" typeface="Phagspa"/>
+        <a:font script="Syrn" typeface="Estrangelo Edessa"/>
+        <a:font script="Syrj" typeface="Estrangelo Edessa"/>
+        <a:font script="Syre" typeface="Estrangelo Edessa"/>
+        <a:font script="Sora" typeface="Nirmala UI"/>
+        <a:font script="Tale" typeface="Microsoft Tai Le"/>
+        <a:font script="Talu" typeface="Microsoft New Tai Lue"/>
+        <a:font script="Tfng" typeface="Ebrima"/>
+      </a:minorFont>
+    </a:fontScheme>
+    <a:fmtScheme name="Office">
+      <a:fillStyleLst>
+        <a:solidFill>
+          <a:schemeClr val="phClr"/>
+        </a:solidFill>
+        <a:gradFill rotWithShape="1">
+          <a:gsLst>
+            <a:gs pos="0">
+              <a:schemeClr val="phClr">
+                <a:lumMod val="110000"/>
+                <a:satMod val="105000"/>
+                <a:tint val="67000"/>
+              </a:schemeClr>
+            </a:gs>
+            <a:gs pos="50000">
+              <a:schemeClr val="phClr">
+                <a:lumMod val="105000"/>
+                <a:satMod val="103000"/>
+                <a:tint val="73000"/>
+              </a:schemeClr>
+            </a:gs>
+            <a:gs pos="100000">
+              <a:schemeClr val="phClr">
+                <a:lumMod val="105000"/>
+                <a:satMod val="109000"/>
+                <a:tint val="81000"/>
+              </a:schemeClr>
+            </a:gs>
+          </a:gsLst>
+          <a:lin ang="5400000" scaled="0"/>
+        </a:gradFill>
+        <a:gradFill rotWithShape="1">
+          <a:gsLst>
+            <a:gs pos="0">
+              <a:schemeClr val="phClr">
+                <a:satMod val="103000"/>
+                <a:lumMod val="102000"/>
+                <a:tint val="94000"/>
+              </a:schemeClr>
+            </a:gs>
+            <a:gs pos="50000">
+              <a:schemeClr val="phClr">
+                <a:satMod val="110000"/>
+                <a:lumMod val="100000"/>
+                <a:shade val="100000"/>
+              </a:schemeClr>
+            </a:gs>
+            <a:gs pos="100000">
+              <a:schemeClr val="phClr">
+                <a:lumMod val="99000"/>
+                <a:satMod val="120000"/>
+                <a:shade val="78000"/>
+              </a:schemeClr>
+            </a:gs>
+          </a:gsLst>
+          <a:lin ang="5400000" scaled="0"/>
+        </a:gradFill>
+      </a:fillStyleLst>
+      <a:lnStyleLst>
+        <a:ln w="12700" cap="flat" cmpd="sng" algn="ctr">
+          <a:solidFill>
+            <a:schemeClr val="phClr"/>
+          </a:solidFill>
+          <a:prstDash val="solid"/>
+          <a:miter lim="800000"/>
+        </a:ln>
+        <a:ln w="19050" cap="flat" cmpd="sng" algn="ctr">
+          <a:solidFill>
+            <a:schemeClr val="phClr"/>
+          </a:solidFill>
+          <a:prstDash val="solid"/>
+          <a:miter lim="800000"/>
+        </a:ln>
+        <a:ln w="25400" cap="flat" cmpd="sng" algn="ctr">
+          <a:solidFill>
+            <a:schemeClr val="phClr"/>
+          </a:solidFill>
+          <a:prstDash val="solid"/>
+          <a:miter lim="800000"/>
+        </a:ln>
+      </a:lnStyleLst>
+      <a:effectStyleLst>
+        <a:effectStyle>
+          <a:effectLst/>
+        </a:effectStyle>
+        <a:effectStyle>
+          <a:effectLst/>
+        </a:effectStyle>
+        <a:effectStyle>
+          <a:effectLst>
+            <a:outerShdw blurRad="57150" dist="19050" dir="5400000" algn="ctr" rotWithShape="0">
+              <a:srgbClr val="000000">
+                <a:alpha val="63000"/>
+              </a:srgbClr>
+            </a:outerShdw>
+          </a:effectLst>
+        </a:effectStyle>
+      </a:effectStyleLst>
+      <a:bgFillStyleLst>
+        <a:solidFill>
+          <a:schemeClr val="phClr"/>
+        </a:solidFill>
+        <a:solidFill>
+          <a:schemeClr val="phClr">
+            <a:tint val="95000"/>
+            <a:satMod val="170000"/>
+          </a:schemeClr>
+        </a:solidFill>
+        <a:gradFill rotWithShape="1">
+          <a:gsLst>
+            <a:gs pos="0">
+              <a:schemeClr val="phClr">
+                <a:tint val="93000"/>
+                <a:satMod val="150000"/>
+                <a:shade val="98000"/>
+                <a:lumMod val="102000"/>
+              </a:schemeClr>
+            </a:gs>
+            <a:gs pos="50000">
+              <a:schemeClr val="phClr">
+                <a:tint val="98000"/>
+                <a:satMod val="130000"/>
+                <a:shade val="90000"/>
+                <a:lumMod val="103000"/>
+              </a:schemeClr>
+            </a:gs>
+            <a:gs pos="100000">
+              <a:schemeClr val="phClr">
+                <a:shade val="63000"/>
+                <a:satMod val="120000"/>
+              </a:schemeClr>
+            </a:gs>
+          </a:gsLst>
+          <a:lin ang="5400000" scaled="0"/>
+        </a:gradFill>
+      </a:bgFillStyleLst>
+    </a:fmtScheme>
+  </a:themeElements>
+  <a:objectDefaults>
+    <a:lnDef>
+      <a:spPr/>
+      <a:bodyPr/>
+      <a:lstStyle/>
+      <a:style>
+        <a:lnRef idx="2">
+          <a:schemeClr val="accent1"/>
+        </a:lnRef>
+        <a:fillRef idx="0">
+          <a:schemeClr val="accent1"/>
+        </a:fillRef>
+        <a:effectRef idx="1">
+          <a:schemeClr val="accent1"/>
+        </a:effectRef>
+        <a:fontRef idx="minor">
+          <a:schemeClr val="tx1"/>
+        </a:fontRef>
+      </a:style>
+    </a:lnDef>
+  </a:objectDefaults>
+  <a:extraClrSchemeLst/>
+  <a:extLst>
+    <a:ext uri="{05A4C25C-085E-4340-85A3-A5531E510DB2}">
+      <thm15:themeFamily xmlns:thm15="http://schemas.microsoft.com/office/thememl/2012/main" name="Office Theme" id="{2E142A2C-CD16-42D6-873A-C26D2A0506FA}" vid="{1BDDFF52-6CD6-40A5-AB3C-68EB2F1E4D0A}"/>
+    </a:ext>
+  </a:extLst>
+</a:theme>
 </file>
</xml_diff>